<commit_message>
Add proposal PPTX: The Law Offices of David P. Shapiro (June 11, 2026)
Co-Authored-By: Claude Sonnet 4.6 <noreply@anthropic.com>
</commit_message>
<xml_diff>
--- a/the-law-offices-of-david-p-shapiro/The_Law_Offices_of_David_P_Shapiro_June_11_2026_Proposal.pptx
+++ b/the-law-offices-of-david-p-shapiro/The_Law_Offices_of_David_P_Shapiro_June_11_2026_Proposal.pptx
@@ -4453,7 +4453,7 @@
                 </a:solidFill>
                 <a:latin typeface="Calibri"/>
               </a:rPr>
-              <a:t>Dead domain davidshapiro.com actively loses referral leads</a:t>
+              <a:t>davidshapiro.com leads to a Baltimore attorney — active lead loss</a:t>
             </a:r>
           </a:p>
         </p:txBody>
@@ -5365,7 +5365,7 @@
                 </a:solidFill>
                 <a:latin typeface="Calibri"/>
               </a:rPr>
-              <a:t>Monder Criminal Lawyer Grp</a:t>
+              <a:t>sandiegoduilawyers.com</a:t>
             </a:r>
           </a:p>
         </p:txBody>
@@ -5398,7 +5398,7 @@
                 </a:solidFill>
                 <a:latin typeface="Calibri"/>
               </a:rPr>
-              <a:t>4.8 stars</a:t>
+              <a:t>N/A</a:t>
             </a:r>
           </a:p>
         </p:txBody>
@@ -5431,7 +5431,7 @@
                 </a:solidFill>
                 <a:latin typeface="Calibri"/>
               </a:rPr>
-              <a:t>Active DUI/criminal presence</a:t>
+              <a:t>Dedicated DUI PPC capture funnel</a:t>
             </a:r>
           </a:p>
         </p:txBody>
@@ -9736,7 +9736,7 @@
                 </a:solidFill>
                 <a:latin typeface="Calibri"/>
               </a:rPr>
-              <a:t>Conservative  (~4 cases/mo):</a:t>
+              <a:t>Conservative  (2–3 cases/mo):</a:t>
             </a:r>
           </a:p>
         </p:txBody>
@@ -9769,7 +9769,7 @@
                 </a:solidFill>
                 <a:latin typeface="Calibri"/>
               </a:rPr>
-              <a:t>$16,000 revenue · 2.9× ROAS</a:t>
+              <a:t>$10,000 revenue · 1.8× ROAS</a:t>
             </a:r>
           </a:p>
         </p:txBody>
@@ -9802,7 +9802,7 @@
                 </a:solidFill>
                 <a:latin typeface="Calibri"/>
               </a:rPr>
-              <a:t>Aggressive  (~23 cases/mo):</a:t>
+              <a:t>Aggressive  (12–13 cases/mo):</a:t>
             </a:r>
           </a:p>
         </p:txBody>
@@ -9835,7 +9835,7 @@
                 </a:solidFill>
                 <a:latin typeface="Calibri"/>
               </a:rPr>
-              <a:t>$92,000 revenue · 4.2× ROAS</a:t>
+              <a:t>$52,000 revenue · 2.4× ROAS</a:t>
             </a:r>
           </a:p>
         </p:txBody>
@@ -9979,7 +9979,7 @@
                 </a:solidFill>
                 <a:latin typeface="Calibri"/>
               </a:rPr>
-              <a:t>Dead domain redirect + coaching kickoff</a:t>
+              <a:t>Coaching kickoff + onboarding begins</a:t>
             </a:r>
           </a:p>
         </p:txBody>

</xml_diff>